<commit_message>
Slides: add a parent's quote to the problem slide
Co-Authored-By: Claude Opus 5.5 <noreply@anthropic.com>
</commit_message>
<xml_diff>
--- a/docs/presentation/Campus-Mithra-Team-Spy.pptx
+++ b/docs/presentation/Campus-Mithra-Team-Spy.pptx
@@ -118,19 +118,19 @@
   <p:extLst>
     <p:ext uri="{521415D9-36F7-43E2-AB2F-B90AF26B5E84}">
       <p14:sectionLst xmlns:p14="http://schemas.microsoft.com/office/powerpoint/2010/main">
-        <p14:section name="Cover" id="{55b67185-1f63-376d-c0f0-5895a286d815}">
+        <p14:section name="Cover" id="{19f8540e-b5c6-82b1-e3e8-6ac7ca6f96cf}">
           <p14:sldIdLst>
             <p14:sldId id="256"/>
           </p14:sldIdLst>
         </p14:section>
-        <p14:section name="Round 1" id="{efacaac6-8622-ac73-5962-fe63c23148de}">
+        <p14:section name="Round 1" id="{154891bf-9bae-3f11-3da4-cdcd19a12d64}">
           <p14:sldIdLst>
             <p14:sldId id="257"/>
             <p14:sldId id="258"/>
             <p14:sldId id="259"/>
           </p14:sldIdLst>
         </p14:section>
-        <p14:section name="Final round" id="{d1d07cf4-b1e4-f0b3-355c-395f7b9cc9a8}">
+        <p14:section name="Final round" id="{a20d539e-16e2-93ee-49c9-eed139ded46a}">
           <p14:sldIdLst>
             <p14:sldId id="260"/>
             <p14:sldId id="261"/>
@@ -141,7 +141,7 @@
             <p14:sldId id="266"/>
           </p14:sldIdLst>
         </p14:section>
-        <p14:section name="Close" id="{53eab68b-fc69-5deb-9fb8-3a148f75b108}">
+        <p14:section name="Close" id="{bc7d72e3-bdaf-cd92-a667-6d08a4241f25}">
           <p14:sldIdLst>
             <p14:sldId id="267"/>
           </p14:sldIdLst>
@@ -6478,15 +6478,32 @@
               <a:buNone/>
             </a:pPr>
             <a:r>
+              <a:rPr lang="en-US" sz="1400" b="1" dirty="0">
+                <a:solidFill>
+                  <a:schemeClr val="tx1"/>
+                </a:solidFill>
+                <a:latin typeface="Calibri" pitchFamily="34" charset="0"/>
+                <a:ea typeface="Calibri" pitchFamily="34" charset="-122"/>
+                <a:cs typeface="Calibri" pitchFamily="34" charset="-120"/>
+              </a:rPr>
+              <a:t>Chidambara, a parent on admission day: </a:t>
+            </a:r>
+            <a:pPr indent="0" marL="0">
+              <a:spcAft>
+                <a:spcPts val="400"/>
+              </a:spcAft>
+              <a:buNone/>
+            </a:pPr>
+            <a:r>
               <a:rPr lang="en-US" sz="1400" i="1" dirty="0">
                 <a:solidFill>
-                  <a:schemeClr val="accent6"/>
-                </a:solidFill>
-                <a:latin typeface="Calibri" pitchFamily="34" charset="0"/>
-                <a:ea typeface="Calibri" pitchFamily="34" charset="-122"/>
-                <a:cs typeface="Calibri" pitchFamily="34" charset="-120"/>
-              </a:rPr>
-              <a:t>Add one real line from a parent or student you asked (who, and what they said).</a:t>
+                  <a:schemeClr val="tx1"/>
+                </a:solidFill>
+                <a:latin typeface="Calibri" pitchFamily="34" charset="0"/>
+                <a:ea typeface="Calibri" pitchFamily="34" charset="-122"/>
+                <a:cs typeface="Calibri" pitchFamily="34" charset="-120"/>
+              </a:rPr>
+              <a:t>"We asked three people where the accounts section was and got three different answers. Nothing at the gate was in Kannada."</a:t>
             </a:r>
             <a:endParaRPr lang="en-US" sz="1400" dirty="0"/>
           </a:p>

</xml_diff>

<commit_message>
Slides and README: demo video link, team year and branch, pricing
Co-Authored-By: Claude Opus 5.5 <noreply@anthropic.com>
</commit_message>
<xml_diff>
--- a/docs/presentation/Campus-Mithra-Team-Spy.pptx
+++ b/docs/presentation/Campus-Mithra-Team-Spy.pptx
@@ -118,19 +118,19 @@
   <p:extLst>
     <p:ext uri="{521415D9-36F7-43E2-AB2F-B90AF26B5E84}">
       <p14:sectionLst xmlns:p14="http://schemas.microsoft.com/office/powerpoint/2010/main">
-        <p14:section name="Cover" id="{19f8540e-b5c6-82b1-e3e8-6ac7ca6f96cf}">
+        <p14:section name="Cover" id="{5d815641-dc7f-0fba-f4dc-61fcf900c439}">
           <p14:sldIdLst>
             <p14:sldId id="256"/>
           </p14:sldIdLst>
         </p14:section>
-        <p14:section name="Round 1" id="{154891bf-9bae-3f11-3da4-cdcd19a12d64}">
+        <p14:section name="Round 1" id="{1575d45b-3d99-59e8-8d0b-14ee144f1ed2}">
           <p14:sldIdLst>
             <p14:sldId id="257"/>
             <p14:sldId id="258"/>
             <p14:sldId id="259"/>
           </p14:sldIdLst>
         </p14:section>
-        <p14:section name="Final round" id="{a20d539e-16e2-93ee-49c9-eed139ded46a}">
+        <p14:section name="Final round" id="{2200d09e-2e35-e6cd-2f2c-c674d4c596a3}">
           <p14:sldIdLst>
             <p14:sldId id="260"/>
             <p14:sldId id="261"/>
@@ -141,7 +141,7 @@
             <p14:sldId id="266"/>
           </p14:sldIdLst>
         </p14:section>
-        <p14:section name="Close" id="{bc7d72e3-bdaf-cd92-a667-6d08a4241f25}">
+        <p14:section name="Close" id="{e26f79df-c803-6119-418f-1023ed55b33f}">
           <p14:sldIdLst>
             <p14:sldId id="267"/>
           </p14:sldIdLst>
@@ -3661,7 +3661,7 @@
                 <a:ea typeface="Calibri" pitchFamily="34" charset="-122"/>
                 <a:cs typeface="Calibri" pitchFamily="34" charset="-120"/>
               </a:rPr>
-              <a:t>₹50,000 – ₹1,50,000 a year per campus, by size</a:t>
+              <a:t>₹3,000 – ₹4,000 a year per campus</a:t>
             </a:r>
             <a:endParaRPr lang="en-US" sz="1400" dirty="0"/>
           </a:p>
@@ -3714,7 +3714,7 @@
                 <a:ea typeface="Calibri" pitchFamily="34" charset="-122"/>
                 <a:cs typeface="Calibri" pitchFamily="34" charset="-120"/>
               </a:rPr>
-              <a:t>one-time; sold or rented for the admission season</a:t>
+              <a:t>about ₹1,500 to build; sold or rented for the admission season</a:t>
             </a:r>
             <a:endParaRPr lang="en-US" sz="1400" dirty="0"/>
           </a:p>
@@ -4148,7 +4148,7 @@
         <p:spPr>
           <a:xfrm>
             <a:off x="548640" y="1417320"/>
-            <a:ext cx="2606040" cy="3749040"/>
+            <a:ext cx="2606040" cy="3200400"/>
           </a:xfrm>
           <a:prstGeom prst="roundRect">
             <a:avLst>
@@ -4278,42 +4278,30 @@
       </p:sp>
       <p:sp>
         <p:nvSpPr>
-          <p:cNvPr id="9" name="Text 7"/>
-          <p:cNvSpPr txBox="1"/>
-          <p:nvPr/>
-        </p:nvSpPr>
-        <p:spPr>
-          <a:xfrm>
-            <a:off x="685800" y="3291840"/>
-            <a:ext cx="2331720" cy="365760"/>
-          </a:xfrm>
-          <a:prstGeom prst="rect">
-            <a:avLst/>
-          </a:prstGeom>
-          <a:noFill/>
-          <a:ln/>
-        </p:spPr>
-        <p:txBody>
-          <a:bodyPr wrap="square" lIns="0" tIns="0" rIns="0" bIns="0" rtlCol="0" anchor="ctr"/>
-          <a:lstStyle/>
-          <a:p>
-            <a:pPr algn="ctr" indent="0" marL="0">
-              <a:buNone/>
-            </a:pPr>
-            <a:r>
-              <a:rPr lang="en-US" sz="1300" i="1" dirty="0">
-                <a:solidFill>
-                  <a:schemeClr val="accent6"/>
-                </a:solidFill>
-                <a:latin typeface="Calibri" pitchFamily="34" charset="0"/>
-                <a:ea typeface="Calibri" pitchFamily="34" charset="-122"/>
-                <a:cs typeface="Calibri" pitchFamily="34" charset="-120"/>
-              </a:rPr>
-              <a:t>Year &amp; branch</a:t>
-            </a:r>
-            <a:endParaRPr lang="en-US" sz="1300" dirty="0"/>
-          </a:p>
-        </p:txBody>
+          <p:cNvPr id="9" name="Year chip 1"/>
+          <p:cNvSpPr/>
+          <p:nvPr/>
+        </p:nvSpPr>
+        <p:spPr>
+          <a:xfrm>
+            <a:off x="1005840" y="3611880"/>
+            <a:ext cx="1691640" cy="347472"/>
+          </a:xfrm>
+          <a:prstGeom prst="roundRect">
+            <a:avLst>
+              <a:gd name="adj" fmla="val 50000"/>
+            </a:avLst>
+          </a:prstGeom>
+          <a:solidFill>
+            <a:schemeClr val="accent1"/>
+          </a:solidFill>
+          <a:ln w="22225">
+            <a:solidFill>
+              <a:schemeClr val="tx1"/>
+            </a:solidFill>
+            <a:prstDash val="solid"/>
+          </a:ln>
+        </p:spPr>
       </p:sp>
       <p:sp>
         <p:nvSpPr>
@@ -4323,34 +4311,34 @@
         </p:nvSpPr>
         <p:spPr>
           <a:xfrm>
-            <a:off x="777240" y="3840480"/>
-            <a:ext cx="2148840" cy="1371600"/>
-          </a:xfrm>
-          <a:prstGeom prst="rect">
-            <a:avLst/>
-          </a:prstGeom>
-          <a:noFill/>
-          <a:ln/>
-        </p:spPr>
-        <p:txBody>
-          <a:bodyPr wrap="square" lIns="0" tIns="0" rIns="0" bIns="0" rtlCol="0" anchor="t"/>
+            <a:off x="1005840" y="3611880"/>
+            <a:ext cx="1691640" cy="347472"/>
+          </a:xfrm>
+          <a:prstGeom prst="rect">
+            <a:avLst/>
+          </a:prstGeom>
+          <a:noFill/>
+          <a:ln/>
+        </p:spPr>
+        <p:txBody>
+          <a:bodyPr wrap="square" lIns="0" tIns="0" rIns="0" bIns="0" rtlCol="0" anchor="ctr"/>
           <a:lstStyle/>
           <a:p>
             <a:pPr algn="ctr" indent="0" marL="0">
               <a:buNone/>
             </a:pPr>
             <a:r>
-              <a:rPr lang="en-US" sz="1300" i="1" dirty="0">
-                <a:solidFill>
-                  <a:schemeClr val="accent6"/>
-                </a:solidFill>
-                <a:latin typeface="Calibri" pitchFamily="34" charset="0"/>
-                <a:ea typeface="Calibri" pitchFamily="34" charset="-122"/>
-                <a:cs typeface="Calibri" pitchFamily="34" charset="-120"/>
-              </a:rPr>
-              <a:t>What they built</a:t>
-            </a:r>
-            <a:endParaRPr lang="en-US" sz="1300" dirty="0"/>
+              <a:rPr lang="en-US" sz="1100" b="1" spc="100" kern="0" dirty="0">
+                <a:solidFill>
+                  <a:schemeClr val="tx1"/>
+                </a:solidFill>
+                <a:latin typeface="Calibri" pitchFamily="34" charset="0"/>
+                <a:ea typeface="Calibri" pitchFamily="34" charset="-122"/>
+                <a:cs typeface="Calibri" pitchFamily="34" charset="-120"/>
+              </a:rPr>
+              <a:t>4TH YEAR  ·  ISE</a:t>
+            </a:r>
+            <a:endParaRPr lang="en-US" sz="1100" dirty="0"/>
           </a:p>
         </p:txBody>
       </p:sp>
@@ -4363,7 +4351,7 @@
         <p:spPr>
           <a:xfrm>
             <a:off x="3383280" y="1417320"/>
-            <a:ext cx="2606040" cy="3749040"/>
+            <a:ext cx="2606040" cy="3200400"/>
           </a:xfrm>
           <a:prstGeom prst="roundRect">
             <a:avLst>
@@ -4493,42 +4481,30 @@
       </p:sp>
       <p:sp>
         <p:nvSpPr>
-          <p:cNvPr id="15" name="Text 13"/>
-          <p:cNvSpPr txBox="1"/>
-          <p:nvPr/>
-        </p:nvSpPr>
-        <p:spPr>
-          <a:xfrm>
-            <a:off x="3520440" y="3291840"/>
-            <a:ext cx="2331720" cy="365760"/>
-          </a:xfrm>
-          <a:prstGeom prst="rect">
-            <a:avLst/>
-          </a:prstGeom>
-          <a:noFill/>
-          <a:ln/>
-        </p:spPr>
-        <p:txBody>
-          <a:bodyPr wrap="square" lIns="0" tIns="0" rIns="0" bIns="0" rtlCol="0" anchor="ctr"/>
-          <a:lstStyle/>
-          <a:p>
-            <a:pPr algn="ctr" indent="0" marL="0">
-              <a:buNone/>
-            </a:pPr>
-            <a:r>
-              <a:rPr lang="en-US" sz="1300" i="1" dirty="0">
-                <a:solidFill>
-                  <a:schemeClr val="accent6"/>
-                </a:solidFill>
-                <a:latin typeface="Calibri" pitchFamily="34" charset="0"/>
-                <a:ea typeface="Calibri" pitchFamily="34" charset="-122"/>
-                <a:cs typeface="Calibri" pitchFamily="34" charset="-120"/>
-              </a:rPr>
-              <a:t>Year &amp; branch</a:t>
-            </a:r>
-            <a:endParaRPr lang="en-US" sz="1300" dirty="0"/>
-          </a:p>
-        </p:txBody>
+          <p:cNvPr id="15" name="Year chip 2"/>
+          <p:cNvSpPr/>
+          <p:nvPr/>
+        </p:nvSpPr>
+        <p:spPr>
+          <a:xfrm>
+            <a:off x="3840480" y="3611880"/>
+            <a:ext cx="1691640" cy="347472"/>
+          </a:xfrm>
+          <a:prstGeom prst="roundRect">
+            <a:avLst>
+              <a:gd name="adj" fmla="val 50000"/>
+            </a:avLst>
+          </a:prstGeom>
+          <a:solidFill>
+            <a:schemeClr val="accent2"/>
+          </a:solidFill>
+          <a:ln w="22225">
+            <a:solidFill>
+              <a:schemeClr val="tx1"/>
+            </a:solidFill>
+            <a:prstDash val="solid"/>
+          </a:ln>
+        </p:spPr>
       </p:sp>
       <p:sp>
         <p:nvSpPr>
@@ -4538,34 +4514,34 @@
         </p:nvSpPr>
         <p:spPr>
           <a:xfrm>
-            <a:off x="3611880" y="3840480"/>
-            <a:ext cx="2148840" cy="1371600"/>
-          </a:xfrm>
-          <a:prstGeom prst="rect">
-            <a:avLst/>
-          </a:prstGeom>
-          <a:noFill/>
-          <a:ln/>
-        </p:spPr>
-        <p:txBody>
-          <a:bodyPr wrap="square" lIns="0" tIns="0" rIns="0" bIns="0" rtlCol="0" anchor="t"/>
+            <a:off x="3840480" y="3611880"/>
+            <a:ext cx="1691640" cy="347472"/>
+          </a:xfrm>
+          <a:prstGeom prst="rect">
+            <a:avLst/>
+          </a:prstGeom>
+          <a:noFill/>
+          <a:ln/>
+        </p:spPr>
+        <p:txBody>
+          <a:bodyPr wrap="square" lIns="0" tIns="0" rIns="0" bIns="0" rtlCol="0" anchor="ctr"/>
           <a:lstStyle/>
           <a:p>
             <a:pPr algn="ctr" indent="0" marL="0">
               <a:buNone/>
             </a:pPr>
             <a:r>
-              <a:rPr lang="en-US" sz="1300" i="1" dirty="0">
-                <a:solidFill>
-                  <a:schemeClr val="accent6"/>
-                </a:solidFill>
-                <a:latin typeface="Calibri" pitchFamily="34" charset="0"/>
-                <a:ea typeface="Calibri" pitchFamily="34" charset="-122"/>
-                <a:cs typeface="Calibri" pitchFamily="34" charset="-120"/>
-              </a:rPr>
-              <a:t>What they built</a:t>
-            </a:r>
-            <a:endParaRPr lang="en-US" sz="1300" dirty="0"/>
+              <a:rPr lang="en-US" sz="1100" b="1" spc="100" kern="0" dirty="0">
+                <a:solidFill>
+                  <a:schemeClr val="tx1"/>
+                </a:solidFill>
+                <a:latin typeface="Calibri" pitchFamily="34" charset="0"/>
+                <a:ea typeface="Calibri" pitchFamily="34" charset="-122"/>
+                <a:cs typeface="Calibri" pitchFamily="34" charset="-120"/>
+              </a:rPr>
+              <a:t>4TH YEAR  ·  ISE</a:t>
+            </a:r>
+            <a:endParaRPr lang="en-US" sz="1100" dirty="0"/>
           </a:p>
         </p:txBody>
       </p:sp>
@@ -4578,7 +4554,7 @@
         <p:spPr>
           <a:xfrm>
             <a:off x="6217920" y="1417320"/>
-            <a:ext cx="2606040" cy="3749040"/>
+            <a:ext cx="2606040" cy="3200400"/>
           </a:xfrm>
           <a:prstGeom prst="roundRect">
             <a:avLst>
@@ -4708,42 +4684,30 @@
       </p:sp>
       <p:sp>
         <p:nvSpPr>
-          <p:cNvPr id="21" name="Text 19"/>
-          <p:cNvSpPr txBox="1"/>
-          <p:nvPr/>
-        </p:nvSpPr>
-        <p:spPr>
-          <a:xfrm>
-            <a:off x="6355080" y="3291840"/>
-            <a:ext cx="2331720" cy="365760"/>
-          </a:xfrm>
-          <a:prstGeom prst="rect">
-            <a:avLst/>
-          </a:prstGeom>
-          <a:noFill/>
-          <a:ln/>
-        </p:spPr>
-        <p:txBody>
-          <a:bodyPr wrap="square" lIns="0" tIns="0" rIns="0" bIns="0" rtlCol="0" anchor="ctr"/>
-          <a:lstStyle/>
-          <a:p>
-            <a:pPr algn="ctr" indent="0" marL="0">
-              <a:buNone/>
-            </a:pPr>
-            <a:r>
-              <a:rPr lang="en-US" sz="1300" i="1" dirty="0">
-                <a:solidFill>
-                  <a:schemeClr val="accent6"/>
-                </a:solidFill>
-                <a:latin typeface="Calibri" pitchFamily="34" charset="0"/>
-                <a:ea typeface="Calibri" pitchFamily="34" charset="-122"/>
-                <a:cs typeface="Calibri" pitchFamily="34" charset="-120"/>
-              </a:rPr>
-              <a:t>Year &amp; branch</a:t>
-            </a:r>
-            <a:endParaRPr lang="en-US" sz="1300" dirty="0"/>
-          </a:p>
-        </p:txBody>
+          <p:cNvPr id="21" name="Year chip 3"/>
+          <p:cNvSpPr/>
+          <p:nvPr/>
+        </p:nvSpPr>
+        <p:spPr>
+          <a:xfrm>
+            <a:off x="6675120" y="3611880"/>
+            <a:ext cx="1691640" cy="347472"/>
+          </a:xfrm>
+          <a:prstGeom prst="roundRect">
+            <a:avLst>
+              <a:gd name="adj" fmla="val 50000"/>
+            </a:avLst>
+          </a:prstGeom>
+          <a:solidFill>
+            <a:schemeClr val="accent3"/>
+          </a:solidFill>
+          <a:ln w="22225">
+            <a:solidFill>
+              <a:schemeClr val="tx1"/>
+            </a:solidFill>
+            <a:prstDash val="solid"/>
+          </a:ln>
+        </p:spPr>
       </p:sp>
       <p:sp>
         <p:nvSpPr>
@@ -4753,34 +4717,34 @@
         </p:nvSpPr>
         <p:spPr>
           <a:xfrm>
-            <a:off x="6446520" y="3840480"/>
-            <a:ext cx="2148840" cy="1371600"/>
-          </a:xfrm>
-          <a:prstGeom prst="rect">
-            <a:avLst/>
-          </a:prstGeom>
-          <a:noFill/>
-          <a:ln/>
-        </p:spPr>
-        <p:txBody>
-          <a:bodyPr wrap="square" lIns="0" tIns="0" rIns="0" bIns="0" rtlCol="0" anchor="t"/>
+            <a:off x="6675120" y="3611880"/>
+            <a:ext cx="1691640" cy="347472"/>
+          </a:xfrm>
+          <a:prstGeom prst="rect">
+            <a:avLst/>
+          </a:prstGeom>
+          <a:noFill/>
+          <a:ln/>
+        </p:spPr>
+        <p:txBody>
+          <a:bodyPr wrap="square" lIns="0" tIns="0" rIns="0" bIns="0" rtlCol="0" anchor="ctr"/>
           <a:lstStyle/>
           <a:p>
             <a:pPr algn="ctr" indent="0" marL="0">
               <a:buNone/>
             </a:pPr>
             <a:r>
-              <a:rPr lang="en-US" sz="1300" i="1" dirty="0">
-                <a:solidFill>
-                  <a:schemeClr val="accent6"/>
-                </a:solidFill>
-                <a:latin typeface="Calibri" pitchFamily="34" charset="0"/>
-                <a:ea typeface="Calibri" pitchFamily="34" charset="-122"/>
-                <a:cs typeface="Calibri" pitchFamily="34" charset="-120"/>
-              </a:rPr>
-              <a:t>What they built</a:t>
-            </a:r>
-            <a:endParaRPr lang="en-US" sz="1300" dirty="0"/>
+              <a:rPr lang="en-US" sz="1100" b="1" spc="100" kern="0" dirty="0">
+                <a:solidFill>
+                  <a:schemeClr val="tx1"/>
+                </a:solidFill>
+                <a:latin typeface="Calibri" pitchFamily="34" charset="0"/>
+                <a:ea typeface="Calibri" pitchFamily="34" charset="-122"/>
+                <a:cs typeface="Calibri" pitchFamily="34" charset="-120"/>
+              </a:rPr>
+              <a:t>4TH YEAR  ·  ISE</a:t>
+            </a:r>
+            <a:endParaRPr lang="en-US" sz="1100" dirty="0"/>
           </a:p>
         </p:txBody>
       </p:sp>
@@ -4793,7 +4757,7 @@
         <p:spPr>
           <a:xfrm>
             <a:off x="9052560" y="1417320"/>
-            <a:ext cx="2606040" cy="3749040"/>
+            <a:ext cx="2606040" cy="3200400"/>
           </a:xfrm>
           <a:prstGeom prst="roundRect">
             <a:avLst>
@@ -4923,42 +4887,30 @@
       </p:sp>
       <p:sp>
         <p:nvSpPr>
-          <p:cNvPr id="27" name="Text 25"/>
-          <p:cNvSpPr txBox="1"/>
-          <p:nvPr/>
-        </p:nvSpPr>
-        <p:spPr>
-          <a:xfrm>
-            <a:off x="9189720" y="3291840"/>
-            <a:ext cx="2331720" cy="365760"/>
-          </a:xfrm>
-          <a:prstGeom prst="rect">
-            <a:avLst/>
-          </a:prstGeom>
-          <a:noFill/>
-          <a:ln/>
-        </p:spPr>
-        <p:txBody>
-          <a:bodyPr wrap="square" lIns="0" tIns="0" rIns="0" bIns="0" rtlCol="0" anchor="ctr"/>
-          <a:lstStyle/>
-          <a:p>
-            <a:pPr algn="ctr" indent="0" marL="0">
-              <a:buNone/>
-            </a:pPr>
-            <a:r>
-              <a:rPr lang="en-US" sz="1300" i="1" dirty="0">
-                <a:solidFill>
-                  <a:schemeClr val="accent6"/>
-                </a:solidFill>
-                <a:latin typeface="Calibri" pitchFamily="34" charset="0"/>
-                <a:ea typeface="Calibri" pitchFamily="34" charset="-122"/>
-                <a:cs typeface="Calibri" pitchFamily="34" charset="-120"/>
-              </a:rPr>
-              <a:t>Year &amp; branch</a:t>
-            </a:r>
-            <a:endParaRPr lang="en-US" sz="1300" dirty="0"/>
-          </a:p>
-        </p:txBody>
+          <p:cNvPr id="27" name="Year chip 4"/>
+          <p:cNvSpPr/>
+          <p:nvPr/>
+        </p:nvSpPr>
+        <p:spPr>
+          <a:xfrm>
+            <a:off x="9509760" y="3611880"/>
+            <a:ext cx="1691640" cy="347472"/>
+          </a:xfrm>
+          <a:prstGeom prst="roundRect">
+            <a:avLst>
+              <a:gd name="adj" fmla="val 50000"/>
+            </a:avLst>
+          </a:prstGeom>
+          <a:solidFill>
+            <a:schemeClr val="accent4"/>
+          </a:solidFill>
+          <a:ln w="22225">
+            <a:solidFill>
+              <a:schemeClr val="tx1"/>
+            </a:solidFill>
+            <a:prstDash val="solid"/>
+          </a:ln>
+        </p:spPr>
       </p:sp>
       <p:sp>
         <p:nvSpPr>
@@ -4968,34 +4920,34 @@
         </p:nvSpPr>
         <p:spPr>
           <a:xfrm>
-            <a:off x="9281160" y="3840480"/>
-            <a:ext cx="2148840" cy="1371600"/>
-          </a:xfrm>
-          <a:prstGeom prst="rect">
-            <a:avLst/>
-          </a:prstGeom>
-          <a:noFill/>
-          <a:ln/>
-        </p:spPr>
-        <p:txBody>
-          <a:bodyPr wrap="square" lIns="0" tIns="0" rIns="0" bIns="0" rtlCol="0" anchor="t"/>
+            <a:off x="9509760" y="3611880"/>
+            <a:ext cx="1691640" cy="347472"/>
+          </a:xfrm>
+          <a:prstGeom prst="rect">
+            <a:avLst/>
+          </a:prstGeom>
+          <a:noFill/>
+          <a:ln/>
+        </p:spPr>
+        <p:txBody>
+          <a:bodyPr wrap="square" lIns="0" tIns="0" rIns="0" bIns="0" rtlCol="0" anchor="ctr"/>
           <a:lstStyle/>
           <a:p>
             <a:pPr algn="ctr" indent="0" marL="0">
               <a:buNone/>
             </a:pPr>
             <a:r>
-              <a:rPr lang="en-US" sz="1300" i="1" dirty="0">
-                <a:solidFill>
-                  <a:schemeClr val="accent6"/>
-                </a:solidFill>
-                <a:latin typeface="Calibri" pitchFamily="34" charset="0"/>
-                <a:ea typeface="Calibri" pitchFamily="34" charset="-122"/>
-                <a:cs typeface="Calibri" pitchFamily="34" charset="-120"/>
-              </a:rPr>
-              <a:t>What they built</a:t>
-            </a:r>
-            <a:endParaRPr lang="en-US" sz="1300" dirty="0"/>
+              <a:rPr lang="en-US" sz="1100" b="1" spc="100" kern="0" dirty="0">
+                <a:solidFill>
+                  <a:schemeClr val="tx1"/>
+                </a:solidFill>
+                <a:latin typeface="Calibri" pitchFamily="34" charset="0"/>
+                <a:ea typeface="Calibri" pitchFamily="34" charset="-122"/>
+                <a:cs typeface="Calibri" pitchFamily="34" charset="-120"/>
+              </a:rPr>
+              <a:t>4TH YEAR  ·  ISE</a:t>
+            </a:r>
+            <a:endParaRPr lang="en-US" sz="1100" dirty="0"/>
           </a:p>
         </p:txBody>
       </p:sp>
@@ -5007,7 +4959,7 @@
         </p:nvSpPr>
         <p:spPr>
           <a:xfrm>
-            <a:off x="548640" y="5486400"/>
+            <a:off x="548640" y="5029200"/>
             <a:ext cx="11064240" cy="502920"/>
           </a:xfrm>
           <a:prstGeom prst="roundRect">
@@ -5041,7 +4993,7 @@
         </p:nvSpPr>
         <p:spPr>
           <a:xfrm>
-            <a:off x="548640" y="5486400"/>
+            <a:off x="548640" y="5029200"/>
             <a:ext cx="11064240" cy="502920"/>
           </a:xfrm>
           <a:prstGeom prst="rect">
@@ -9759,7 +9711,7 @@
                 <a:ea typeface="Arial Black" pitchFamily="34" charset="-122"/>
                 <a:cs typeface="Arial Black" pitchFamily="34" charset="-120"/>
               </a:rPr>
-              <a:t>₹2–3k</a:t>
+              <a:t>₹1.5k</a:t>
             </a:r>
             <a:endParaRPr lang="en-US" sz="2600" dirty="0"/>
           </a:p>
@@ -9776,7 +9728,7 @@
                 <a:ea typeface="Calibri" pitchFamily="34" charset="-122"/>
                 <a:cs typeface="Calibri" pitchFamily="34" charset="-120"/>
               </a:rPr>
-              <a:t>kiosk electronics</a:t>
+              <a:t>kiosk hardware build</a:t>
             </a:r>
             <a:endParaRPr lang="en-US" sz="2600" dirty="0"/>
           </a:p>
@@ -9841,7 +9793,7 @@
               <a:buNone/>
             </a:pPr>
             <a:r>
-              <a:rPr lang="en-US" sz="1800" dirty="0">
+              <a:rPr lang="en-US" sz="2400" dirty="0">
                 <a:solidFill>
                   <a:schemeClr val="tx1"/>
                 </a:solidFill>
@@ -9849,9 +9801,9 @@
                 <a:ea typeface="Arial Black" pitchFamily="34" charset="-122"/>
                 <a:cs typeface="Arial Black" pitchFamily="34" charset="-120"/>
               </a:rPr>
-              <a:t>USB 921600</a:t>
-            </a:r>
-            <a:endParaRPr lang="en-US" sz="1800" dirty="0"/>
+              <a:t>USB</a:t>
+            </a:r>
+            <a:endParaRPr lang="en-US" sz="2400" dirty="0"/>
           </a:p>
           <a:p>
             <a:pPr algn="ctr" indent="0" marL="0">
@@ -9866,9 +9818,9 @@
                 <a:ea typeface="Calibri" pitchFamily="34" charset="-122"/>
                 <a:cs typeface="Calibri" pitchFamily="34" charset="-120"/>
               </a:rPr>
-              <a:t>baud to the PC — no Wi-Fi keys on the device</a:t>
-            </a:r>
-            <a:endParaRPr lang="en-US" sz="1800" dirty="0"/>
+              <a:t>link to the PC — no Wi-Fi keys on the device</a:t>
+            </a:r>
+            <a:endParaRPr lang="en-US" sz="2400" dirty="0"/>
           </a:p>
         </p:txBody>
       </p:sp>
@@ -11927,15 +11879,22 @@
               <a:buNone/>
             </a:pPr>
             <a:r>
-              <a:rPr lang="en-US" sz="1200" b="1" i="1" dirty="0">
-                <a:solidFill>
-                  <a:schemeClr val="accent6"/>
-                </a:solidFill>
-                <a:latin typeface="Calibri" pitchFamily="34" charset="0"/>
-                <a:ea typeface="Calibri" pitchFamily="34" charset="-122"/>
-                <a:cs typeface="Calibri" pitchFamily="34" charset="-120"/>
-              </a:rPr>
-              <a:t>Paste the video link</a:t>
+              <a:rPr lang="en-US" sz="1200" b="1" u="sng" dirty="0">
+                <a:solidFill>
+                  <a:schemeClr val="tx1"/>
+                </a:solidFill>
+                <a:latin typeface="Calibri" pitchFamily="34" charset="0"/>
+                <a:ea typeface="Calibri" pitchFamily="34" charset="-122"/>
+                <a:cs typeface="Calibri" pitchFamily="34" charset="-120"/>
+                <a:hlinkClick r:id="rId2" invalidUrl="" action="" tgtFrame="" tooltip="" history="1" highlightClick="0" endSnd="0">
+                  <a:extLst>
+                    <a:ext uri="{A12FA001-AC4F-418D-AE19-62706E023703}">
+                      <ahyp:hlinkClr xmlns:ahyp="http://schemas.microsoft.com/office/drawing/2018/hyperlinkcolor" val="tx"/>
+                    </a:ext>
+                  </a:extLst>
+                </a:hlinkClick>
+              </a:rPr>
+              <a:t>youtu.be/tY1Hf34JIiQ</a:t>
             </a:r>
             <a:endParaRPr lang="en-US" sz="1200" dirty="0"/>
           </a:p>
@@ -12112,7 +12071,7 @@
                 <a:latin typeface="Calibri" pitchFamily="34" charset="0"/>
                 <a:ea typeface="Calibri" pitchFamily="34" charset="-122"/>
                 <a:cs typeface="Calibri" pitchFamily="34" charset="-120"/>
-                <a:hlinkClick r:id="rId2" invalidUrl="" action="" tgtFrame="" tooltip="" history="1" highlightClick="0" endSnd="0">
+                <a:hlinkClick r:id="rId3" invalidUrl="" action="" tgtFrame="" tooltip="" history="1" highlightClick="0" endSnd="0">
                   <a:extLst>
                     <a:ext uri="{A12FA001-AC4F-418D-AE19-62706E023703}">
                       <ahyp:hlinkClr xmlns:ahyp="http://schemas.microsoft.com/office/drawing/2018/hyperlinkcolor" val="tx"/>
@@ -12167,7 +12126,7 @@
           <p:nvPr/>
         </p:nvPicPr>
         <p:blipFill>
-          <a:blip r:embed="rId3"/>
+          <a:blip r:embed="rId4"/>
           <a:srcRect l="0" r="0" t="0" b="0"/>
           <a:stretch/>
         </p:blipFill>
@@ -12222,7 +12181,7 @@
           <p:nvPr/>
         </p:nvPicPr>
         <p:blipFill>
-          <a:blip r:embed="rId4"/>
+          <a:blip r:embed="rId5"/>
           <a:srcRect l="0" r="0" t="0" b="0"/>
           <a:stretch/>
         </p:blipFill>
@@ -12279,7 +12238,7 @@
           <p:nvPr/>
         </p:nvPicPr>
         <p:blipFill>
-          <a:blip r:embed="rId5"/>
+          <a:blip r:embed="rId6"/>
           <a:srcRect l="0" r="0" t="0" b="0"/>
           <a:stretch/>
         </p:blipFill>
@@ -12363,7 +12322,7 @@
           <p:nvPr/>
         </p:nvPicPr>
         <p:blipFill>
-          <a:blip r:embed="rId6"/>
+          <a:blip r:embed="rId7"/>
           <a:srcRect l="0" r="0" t="0" b="0"/>
           <a:stretch/>
         </p:blipFill>

</xml_diff>